<commit_message>
docs: QA1(TTFT) baseline을 CacheBlend로 재정의 — 이중 기준선 구조
목표 1의 실행 기반을 vLLM+CacheBlend(LMCache 계열) 채택 후 수정·확장으로
확정(FR-02·DP1 사전 입력). QA1 주 기준선 = CacheBlend 공개 구현(수정의
순기여 판정), 보조 기준선 = 무재사용 구성(효용 확인·문헌 비교·QA2 정합).
★★★ = CacheBlend 대비 평균 TTFT ≥1.3× AND 무재사용 대비 ≥2×. 1.3×는
잔여 TTFT 주성분(선택 재계산 10–15%·복원 I/O·커버리지 밖 full prefill)
회수 논증(C)·잠정 — 파일럿 실측 후 재캘리브레이션 명시. 보조 지표에
재사용 커버리지·재계산율·복원 판단 적중률 추가. 필요성 슬라이드 목표 1
판정 갱신

Co-Authored-By: Claude Fable 5 <noreply@anthropic.com>
Claude-Session: https://claude.ai/code/session_01LUTEtkPq1rWG3s1m55RqtN
</commit_message>
<xml_diff>
--- a/docs/mcr_necessity_kv.pptx
+++ b/docs/mcr_necessity_kv.pptx
@@ -2498,7 +2498,7 @@
                 <a:ea typeface="Malgun Gothic" pitchFamily="34" charset="-122"/>
                 <a:cs typeface="Malgun Gothic" pitchFamily="34" charset="-120"/>
               </a:rPr>
-              <a:t>prefix + 비접두(chunk) 재사용 · 세션/사용자 영속화 · 복원 vs 재계산 비용 판단 (FR-02)</a:t>
+              <a:t>SOTA(CacheBlend) 채택 후 수정·확장 — 비접두 재사용 확장 · 세션/사용자 영속화 · 복원 vs 재계산 비용 판단 (FR-02)</a:t>
             </a:r>
             <a:endParaRPr lang="en-US" sz="980" dirty="0"/>
           </a:p>
@@ -2529,7 +2529,7 @@
                 <a:ea typeface="Malgun Gothic" pitchFamily="34" charset="-122"/>
                 <a:cs typeface="Malgun Gothic" pitchFamily="34" charset="-120"/>
               </a:rPr>
-              <a:t>TTFT ≥ 2× (QA1) — CacheBlend 2.2–3.3×(B) 앵커</a:t>
+              <a:t>CacheBlend 대비 TTFT ≥ 1.3×(잠정) · 무재사용 대비 ≥ 2× (QA1)</a:t>
             </a:r>
             <a:endParaRPr lang="en-US" sz="980" dirty="0"/>
           </a:p>

</xml_diff>

<commit_message>
Revert "docs: QA1(TTFT) baseline을 CacheBlend로 재정의 — 이중 기준선 구조"
목표 1의 CacheBlend 기준선 채택을 취소 — QA1을 무재사용(GPU HBM 단일
tier) 단일 baseline · ★★★ ≥2× 체계로 원복. FR-02의 실행 기반 확정
문구(CacheBlend 채택 후 수정·확장)와 QA 정의 v1.3 / 도출 v0.9 /
요구사항 v1.3 개정, 슬라이드 목표 1 판정 문구를 모두 되돌림

This reverts commit a85a958.

Co-Authored-By: Claude Fable 5 <noreply@anthropic.com>
Claude-Session: https://claude.ai/code/session_01LUTEtkPq1rWG3s1m55RqtN
</commit_message>
<xml_diff>
--- a/docs/mcr_necessity_kv.pptx
+++ b/docs/mcr_necessity_kv.pptx
@@ -2498,7 +2498,7 @@
                 <a:ea typeface="Malgun Gothic" pitchFamily="34" charset="-122"/>
                 <a:cs typeface="Malgun Gothic" pitchFamily="34" charset="-120"/>
               </a:rPr>
-              <a:t>SOTA(CacheBlend) 채택 후 수정·확장 — 비접두 재사용 확장 · 세션/사용자 영속화 · 복원 vs 재계산 비용 판단 (FR-02)</a:t>
+              <a:t>prefix + 비접두(chunk) 재사용 · 세션/사용자 영속화 · 복원 vs 재계산 비용 판단 (FR-02)</a:t>
             </a:r>
             <a:endParaRPr lang="en-US" sz="980" dirty="0"/>
           </a:p>
@@ -2529,7 +2529,7 @@
                 <a:ea typeface="Malgun Gothic" pitchFamily="34" charset="-122"/>
                 <a:cs typeface="Malgun Gothic" pitchFamily="34" charset="-120"/>
               </a:rPr>
-              <a:t>CacheBlend 대비 TTFT ≥ 1.3×(잠정) · 무재사용 대비 ≥ 2× (QA1)</a:t>
+              <a:t>TTFT ≥ 2× (QA1) — CacheBlend 2.2–3.3×(B) 앵커</a:t>
             </a:r>
             <a:endParaRPr lang="en-US" sz="980" dirty="0"/>
           </a:p>

</xml_diff>